<commit_message>
docs: Remove Smart India Hackathon subtitle from title slide and delete redundant presentation file
</commit_message>
<xml_diff>
--- a/docs/detailed_presentation.pptx
+++ b/docs/detailed_presentation.pptx
@@ -3158,19 +3158,6 @@
             </a:pPr>
             <a:r>
               <a:t>AI-Powered Digital Public Safety Platform for Proactive Cyber-Fraud Mitigation</a:t>
-            </a:r>
-          </a:p>
-          <a:p>
-            <a:pPr>
-              <a:defRPr sz="1200">
-                <a:solidFill>
-                  <a:srgbClr val="A855F7"/>
-                </a:solidFill>
-                <a:latin typeface="Arial"/>
-              </a:defRPr>
-            </a:pPr>
-            <a:r>
-              <a:t>Smart India Hackathon 2024 | Problem Statement ID: SIH-1650</a:t>
             </a:r>
           </a:p>
         </p:txBody>

</xml_diff>